<commit_message>
docs: adicionando a imagens das telas, visao de interacao do usuario
</commit_message>
<xml_diff>
--- a/Apresentação/FAI_SI_AE_IV-Slides 2 PetLink.pptx
+++ b/Apresentação/FAI_SI_AE_IV-Slides 2 PetLink.pptx
@@ -5,17 +5,18 @@
     <p:sldMasterId id="2147483648" r:id="rId1"/>
   </p:sldMasterIdLst>
   <p:notesMasterIdLst>
-    <p:notesMasterId r:id="rId10"/>
+    <p:notesMasterId r:id="rId11"/>
   </p:notesMasterIdLst>
   <p:sldIdLst>
     <p:sldId id="256" r:id="rId2"/>
     <p:sldId id="275" r:id="rId3"/>
     <p:sldId id="287" r:id="rId4"/>
-    <p:sldId id="296" r:id="rId5"/>
-    <p:sldId id="295" r:id="rId6"/>
-    <p:sldId id="294" r:id="rId7"/>
+    <p:sldId id="299" r:id="rId5"/>
+    <p:sldId id="296" r:id="rId6"/>
+    <p:sldId id="295" r:id="rId7"/>
     <p:sldId id="297" r:id="rId8"/>
-    <p:sldId id="298" r:id="rId9"/>
+    <p:sldId id="300" r:id="rId9"/>
+    <p:sldId id="298" r:id="rId10"/>
   </p:sldIdLst>
   <p:sldSz cx="13004800" cy="9753600"/>
   <p:notesSz cx="6858000" cy="9144000"/>
@@ -2827,7 +2828,7 @@
           </a:ln>
           <a:extLst>
             <a:ext uri="{C572A759-6A51-4108-AA02-DFA0A04FC94B}">
-              <ma14:wrappingTextBoxFlag xmlns:ma14="http://schemas.microsoft.com/office/mac/drawingml/2011/main" xmlns:a14="http://schemas.microsoft.com/office/drawing/2010/main" xmlns:m="http://schemas.openxmlformats.org/officeDocument/2006/math" xmlns="" val="1"/>
+              <ma14:wrappingTextBoxFlag xmlns="" xmlns:m="http://schemas.openxmlformats.org/officeDocument/2006/math" xmlns:a14="http://schemas.microsoft.com/office/drawing/2010/main" xmlns:ma14="http://schemas.microsoft.com/office/mac/drawingml/2011/main" val="1"/>
             </a:ext>
           </a:extLst>
         </p:spPr>
@@ -2882,7 +2883,7 @@
           </a:ln>
           <a:extLst>
             <a:ext uri="{C572A759-6A51-4108-AA02-DFA0A04FC94B}">
-              <ma14:wrappingTextBoxFlag xmlns:ma14="http://schemas.microsoft.com/office/mac/drawingml/2011/main" xmlns:a14="http://schemas.microsoft.com/office/drawing/2010/main" xmlns:m="http://schemas.openxmlformats.org/officeDocument/2006/math" xmlns="" val="1"/>
+              <ma14:wrappingTextBoxFlag xmlns="" xmlns:m="http://schemas.openxmlformats.org/officeDocument/2006/math" xmlns:a14="http://schemas.microsoft.com/office/drawing/2010/main" xmlns:ma14="http://schemas.microsoft.com/office/mac/drawingml/2011/main" val="1"/>
             </a:ext>
           </a:extLst>
         </p:spPr>
@@ -3830,44 +3831,42 @@
           <a:chExt cx="0" cy="0"/>
         </a:xfrm>
       </p:grpSpPr>
-      <p:sp>
-        <p:nvSpPr>
-          <p:cNvPr id="154" name="Título da Apresentação"/>
-          <p:cNvSpPr txBox="1">
-            <a:spLocks noGrp="1"/>
-          </p:cNvSpPr>
-          <p:nvPr>
-            <p:ph type="ctrTitle" idx="4294967295"/>
-          </p:nvPr>
-        </p:nvSpPr>
+      <p:pic>
+        <p:nvPicPr>
+          <p:cNvPr id="3" name="Picture 2">
+            <a:extLst>
+              <a:ext uri="{FF2B5EF4-FFF2-40B4-BE49-F238E27FC236}">
+                <a16:creationId xmlns:a16="http://schemas.microsoft.com/office/drawing/2014/main" id="{68F55480-27D4-646C-79CD-B1272BA6A935}"/>
+              </a:ext>
+            </a:extLst>
+          </p:cNvPr>
+          <p:cNvPicPr>
+            <a:picLocks noChangeAspect="1"/>
+          </p:cNvPicPr>
+          <p:nvPr/>
+        </p:nvPicPr>
+        <p:blipFill>
+          <a:blip r:embed="rId3">
+            <a:extLst>
+              <a:ext uri="{28A0092B-C50C-407E-A947-70E740481C1C}">
+                <a14:useLocalDpi xmlns:a14="http://schemas.microsoft.com/office/drawing/2010/main" val="0"/>
+              </a:ext>
+            </a:extLst>
+          </a:blip>
+          <a:stretch>
+            <a:fillRect/>
+          </a:stretch>
+        </p:blipFill>
         <p:spPr>
           <a:xfrm>
-            <a:off x="697871" y="4409616"/>
-            <a:ext cx="11609057" cy="934368"/>
+            <a:off x="3356986" y="1731386"/>
+            <a:ext cx="6290828" cy="6290828"/>
           </a:xfrm>
           <a:prstGeom prst="rect">
             <a:avLst/>
           </a:prstGeom>
         </p:spPr>
-        <p:txBody>
-          <a:bodyPr>
-            <a:normAutofit/>
-          </a:bodyPr>
-          <a:lstStyle/>
-          <a:p>
-            <a:pPr algn="ctr"/>
-            <a:r>
-              <a:rPr lang="en-US" dirty="0"/>
-              <a:t>P</a:t>
-            </a:r>
-            <a:r>
-              <a:rPr lang="pt-BR" dirty="0" err="1"/>
-              <a:t>etLink</a:t>
-            </a:r>
-            <a:endParaRPr dirty="0"/>
-          </a:p>
-        </p:txBody>
-      </p:sp>
+      </p:pic>
     </p:spTree>
     <p:extLst>
       <p:ext uri="{BB962C8B-B14F-4D97-AF65-F5344CB8AC3E}">
@@ -3939,7 +3938,7 @@
             <a:pPr algn="ctr"/>
             <a:r>
               <a:rPr lang="pt-BR" dirty="0"/>
-              <a:t>Sobre</a:t>
+              <a:t>Apresentação do projeto</a:t>
             </a:r>
             <a:endParaRPr dirty="0"/>
           </a:p>
@@ -3959,8 +3958,8 @@
         </p:nvSpPr>
         <p:spPr>
           <a:xfrm>
-            <a:off x="0" y="2855735"/>
-            <a:ext cx="13004799" cy="4042132"/>
+            <a:off x="2181920" y="1852464"/>
+            <a:ext cx="8640960" cy="6996787"/>
           </a:xfrm>
           <a:prstGeom prst="rect">
             <a:avLst/>
@@ -3993,7 +3992,7 @@
           <a:p>
             <a:r>
               <a:rPr lang="pt-BR" sz="3200" dirty="0"/>
-              <a:t>Organização das etapas do projeto</a:t>
+              <a:t>Vacinação</a:t>
             </a:r>
           </a:p>
           <a:p>
@@ -4002,7 +4001,7 @@
           <a:p>
             <a:r>
               <a:rPr lang="pt-BR" sz="3200" dirty="0"/>
-              <a:t>Definição dos recursos necessários</a:t>
+              <a:t>Doação</a:t>
             </a:r>
           </a:p>
           <a:p>
@@ -4011,7 +4010,7 @@
           <a:p>
             <a:r>
               <a:rPr lang="pt-BR" sz="3200" dirty="0"/>
-              <a:t>Estrutura para desenvolvimento do sistema</a:t>
+              <a:t>Adoção</a:t>
             </a:r>
           </a:p>
           <a:p>
@@ -4020,42 +4019,38 @@
           <a:p>
             <a:r>
               <a:rPr lang="pt-BR" sz="3200" dirty="0"/>
-              <a:t>Base para execução e acompanhamento</a:t>
+              <a:t>Campanhas de Adoção</a:t>
             </a:r>
           </a:p>
           <a:p>
-            <a:pPr marL="0" marR="0" indent="0" algn="ctr" defTabSz="1733930" rtl="0" fontAlgn="auto" latinLnBrk="0" hangingPunct="0">
-              <a:lnSpc>
-                <a:spcPct val="100000"/>
-              </a:lnSpc>
-              <a:spcBef>
-                <a:spcPts val="0"/>
-              </a:spcBef>
-              <a:spcAft>
-                <a:spcPts val="0"/>
-              </a:spcAft>
-              <a:buClrTx/>
-              <a:buSzTx/>
-              <a:buFontTx/>
-              <a:buNone/>
-              <a:tabLst/>
-            </a:pPr>
-            <a:endParaRPr kumimoji="0" lang="pt-BR" sz="3200" b="0" i="0" u="none" strike="noStrike" cap="none" spc="0" normalizeH="0" baseline="0" dirty="0">
-              <a:ln>
-                <a:noFill/>
-              </a:ln>
-              <a:solidFill>
-                <a:schemeClr val="bg2">
-                  <a:lumMod val="10000"/>
-                </a:schemeClr>
-              </a:solidFill>
-              <a:effectLst/>
-              <a:uFillTx/>
-              <a:latin typeface="+mn-lt"/>
-              <a:ea typeface="+mn-ea"/>
-              <a:cs typeface="+mn-cs"/>
-              <a:sym typeface="Helvetica Neue"/>
-            </a:endParaRPr>
+            <a:endParaRPr lang="pt-BR" sz="3200" dirty="0"/>
+          </a:p>
+          <a:p>
+            <a:r>
+              <a:rPr lang="pt-BR" sz="3200" dirty="0"/>
+              <a:t>Campanhas de Vacinação</a:t>
+            </a:r>
+          </a:p>
+          <a:p>
+            <a:endParaRPr lang="pt-BR" sz="3200" dirty="0"/>
+          </a:p>
+          <a:p>
+            <a:r>
+              <a:rPr lang="pt-BR" sz="3200" dirty="0"/>
+              <a:t>Disque denuncia sobre maus tratos</a:t>
+            </a:r>
+          </a:p>
+          <a:p>
+            <a:endParaRPr lang="pt-BR" sz="3200" dirty="0"/>
+          </a:p>
+          <a:p>
+            <a:r>
+              <a:rPr lang="pt-BR" sz="3200" dirty="0"/>
+              <a:t>Animais perdidos</a:t>
+            </a:r>
+          </a:p>
+          <a:p>
+            <a:endParaRPr lang="pt-BR" sz="3200" dirty="0"/>
           </a:p>
         </p:txBody>
       </p:sp>
@@ -4074,6 +4069,217 @@
 </file>
 
 <file path=ppt/slides/slide4.xml><?xml version="1.0" encoding="utf-8"?>
+<p:sld xmlns:a="http://schemas.openxmlformats.org/drawingml/2006/main" xmlns:r="http://schemas.openxmlformats.org/officeDocument/2006/relationships" xmlns:p="http://schemas.openxmlformats.org/presentationml/2006/main">
+  <p:cSld>
+    <p:bg>
+      <p:bgPr>
+        <a:blipFill rotWithShape="1">
+          <a:blip r:embed="rId2"/>
+          <a:srcRect/>
+          <a:stretch>
+            <a:fillRect/>
+          </a:stretch>
+        </a:blipFill>
+        <a:effectLst/>
+      </p:bgPr>
+    </p:bg>
+    <p:spTree>
+      <p:nvGrpSpPr>
+        <p:cNvPr id="1" name="">
+          <a:extLst>
+            <a:ext uri="{FF2B5EF4-FFF2-40B4-BE49-F238E27FC236}">
+              <a16:creationId xmlns:a16="http://schemas.microsoft.com/office/drawing/2014/main" id="{8ACEACB2-A43A-0AC8-CDDD-BD48213C3342}"/>
+            </a:ext>
+          </a:extLst>
+        </p:cNvPr>
+        <p:cNvGrpSpPr/>
+        <p:nvPr/>
+      </p:nvGrpSpPr>
+      <p:grpSpPr>
+        <a:xfrm>
+          <a:off x="0" y="0"/>
+          <a:ext cx="0" cy="0"/>
+          <a:chOff x="0" y="0"/>
+          <a:chExt cx="0" cy="0"/>
+        </a:xfrm>
+      </p:grpSpPr>
+      <p:sp>
+        <p:nvSpPr>
+          <p:cNvPr id="154" name="Título da Apresentação">
+            <a:extLst>
+              <a:ext uri="{FF2B5EF4-FFF2-40B4-BE49-F238E27FC236}">
+                <a16:creationId xmlns:a16="http://schemas.microsoft.com/office/drawing/2014/main" id="{50E464D0-6A98-8871-6F2C-FF361A4BF37B}"/>
+              </a:ext>
+            </a:extLst>
+          </p:cNvPr>
+          <p:cNvSpPr txBox="1">
+            <a:spLocks noGrp="1"/>
+          </p:cNvSpPr>
+          <p:nvPr>
+            <p:ph type="ctrTitle" idx="4294967295"/>
+          </p:nvPr>
+        </p:nvSpPr>
+        <p:spPr>
+          <a:xfrm>
+            <a:off x="2325936" y="484312"/>
+            <a:ext cx="10225136" cy="1512168"/>
+          </a:xfrm>
+          <a:prstGeom prst="rect">
+            <a:avLst/>
+          </a:prstGeom>
+        </p:spPr>
+        <p:txBody>
+          <a:bodyPr>
+            <a:normAutofit/>
+          </a:bodyPr>
+          <a:lstStyle/>
+          <a:p>
+            <a:pPr algn="ctr"/>
+            <a:r>
+              <a:rPr lang="pt-BR" dirty="0"/>
+              <a:t>Objetivo</a:t>
+            </a:r>
+          </a:p>
+        </p:txBody>
+      </p:sp>
+      <p:pic>
+        <p:nvPicPr>
+          <p:cNvPr id="4" name="Picture 3">
+            <a:extLst>
+              <a:ext uri="{FF2B5EF4-FFF2-40B4-BE49-F238E27FC236}">
+                <a16:creationId xmlns:a16="http://schemas.microsoft.com/office/drawing/2014/main" id="{D733F0D9-E026-94DC-BBFE-AAEBC6D7CE1C}"/>
+              </a:ext>
+            </a:extLst>
+          </p:cNvPr>
+          <p:cNvPicPr>
+            <a:picLocks noChangeAspect="1"/>
+          </p:cNvPicPr>
+          <p:nvPr/>
+        </p:nvPicPr>
+        <p:blipFill>
+          <a:blip r:embed="rId3">
+            <a:extLst>
+              <a:ext uri="{28A0092B-C50C-407E-A947-70E740481C1C}">
+                <a14:useLocalDpi xmlns:a14="http://schemas.microsoft.com/office/drawing/2010/main" val="0"/>
+              </a:ext>
+            </a:extLst>
+          </a:blip>
+          <a:stretch>
+            <a:fillRect/>
+          </a:stretch>
+        </p:blipFill>
+        <p:spPr>
+          <a:xfrm>
+            <a:off x="7307045" y="1780456"/>
+            <a:ext cx="5244027" cy="6369028"/>
+          </a:xfrm>
+          <a:prstGeom prst="rect">
+            <a:avLst/>
+          </a:prstGeom>
+        </p:spPr>
+      </p:pic>
+      <p:sp>
+        <p:nvSpPr>
+          <p:cNvPr id="5" name="CaixaDeTexto 1">
+            <a:extLst>
+              <a:ext uri="{FF2B5EF4-FFF2-40B4-BE49-F238E27FC236}">
+                <a16:creationId xmlns:a16="http://schemas.microsoft.com/office/drawing/2014/main" id="{F26CFA46-734B-050F-580A-F54F3680F9B4}"/>
+              </a:ext>
+            </a:extLst>
+          </p:cNvPr>
+          <p:cNvSpPr txBox="1"/>
+          <p:nvPr/>
+        </p:nvSpPr>
+        <p:spPr>
+          <a:xfrm>
+            <a:off x="309712" y="3504003"/>
+            <a:ext cx="6624736" cy="3549690"/>
+          </a:xfrm>
+          <a:prstGeom prst="rect">
+            <a:avLst/>
+          </a:prstGeom>
+          <a:noFill/>
+          <a:ln w="12700" cap="flat">
+            <a:noFill/>
+            <a:miter lim="400000"/>
+          </a:ln>
+          <a:effectLst/>
+          <a:sp3d/>
+        </p:spPr>
+        <p:style>
+          <a:lnRef idx="0">
+            <a:scrgbClr r="0" g="0" b="0"/>
+          </a:lnRef>
+          <a:fillRef idx="0">
+            <a:scrgbClr r="0" g="0" b="0"/>
+          </a:fillRef>
+          <a:effectRef idx="0">
+            <a:scrgbClr r="0" g="0" b="0"/>
+          </a:effectRef>
+          <a:fontRef idx="none"/>
+        </p:style>
+        <p:txBody>
+          <a:bodyPr rot="0" spcFirstLastPara="1" vertOverflow="overflow" horzOverflow="overflow" vert="horz" wrap="square" lIns="50800" tIns="50800" rIns="50800" bIns="50800" numCol="1" spcCol="38100" rtlCol="0" anchor="ctr">
+            <a:spAutoFit/>
+          </a:bodyPr>
+          <a:lstStyle/>
+          <a:p>
+            <a:pPr algn="l"/>
+            <a:r>
+              <a:rPr lang="pt-BR" sz="3200" dirty="0"/>
+              <a:t>Incentivar a Vacinação de animais</a:t>
+            </a:r>
+          </a:p>
+          <a:p>
+            <a:pPr algn="l"/>
+            <a:endParaRPr lang="pt-BR" sz="3200" dirty="0"/>
+          </a:p>
+          <a:p>
+            <a:pPr algn="l"/>
+            <a:r>
+              <a:rPr lang="pt-BR" sz="3200" dirty="0"/>
+              <a:t>Doação e Adoção Responsável </a:t>
+            </a:r>
+          </a:p>
+          <a:p>
+            <a:pPr algn="l"/>
+            <a:endParaRPr lang="pt-BR" sz="3200" dirty="0"/>
+          </a:p>
+          <a:p>
+            <a:pPr algn="l"/>
+            <a:r>
+              <a:rPr lang="pt-BR" sz="3200" dirty="0"/>
+              <a:t>Diminuir Maus tratos</a:t>
+            </a:r>
+          </a:p>
+          <a:p>
+            <a:pPr algn="l"/>
+            <a:endParaRPr lang="pt-BR" sz="3200" dirty="0"/>
+          </a:p>
+          <a:p>
+            <a:pPr algn="l"/>
+            <a:r>
+              <a:rPr lang="pt-BR" sz="3200" dirty="0"/>
+              <a:t>Facilitar a vida do tutor</a:t>
+            </a:r>
+          </a:p>
+        </p:txBody>
+      </p:sp>
+    </p:spTree>
+    <p:extLst>
+      <p:ext uri="{BB962C8B-B14F-4D97-AF65-F5344CB8AC3E}">
+        <p14:creationId xmlns:p14="http://schemas.microsoft.com/office/powerpoint/2010/main" val="1990375604"/>
+      </p:ext>
+    </p:extLst>
+  </p:cSld>
+  <p:clrMapOvr>
+    <a:masterClrMapping/>
+  </p:clrMapOvr>
+  <p:transition spd="med"/>
+</p:sld>
+</file>
+
+<file path=ppt/slides/slide5.xml><?xml version="1.0" encoding="utf-8"?>
 <p:sld xmlns:a="http://schemas.openxmlformats.org/drawingml/2006/main" xmlns:r="http://schemas.openxmlformats.org/officeDocument/2006/relationships" xmlns:p="http://schemas.openxmlformats.org/presentationml/2006/main">
   <p:cSld>
     <p:bg>
@@ -4162,8 +4368,8 @@
         </p:nvSpPr>
         <p:spPr>
           <a:xfrm>
-            <a:off x="0" y="2860863"/>
-            <a:ext cx="13004800" cy="4031873"/>
+            <a:off x="453728" y="1636440"/>
+            <a:ext cx="13004800" cy="6740307"/>
           </a:xfrm>
           <a:prstGeom prst="rect">
             <a:avLst/>
@@ -4194,46 +4400,385 @@
           </a:bodyPr>
           <a:lstStyle/>
           <a:p>
+            <a:pPr algn="l"/>
             <a:r>
-              <a:rPr lang="pt-BR" sz="3200" dirty="0"/>
-              <a:t>Cadastro de usuários e pets</a:t>
+              <a:rPr lang="pt-BR" sz="1800" b="1" dirty="0">
+                <a:solidFill>
+                  <a:schemeClr val="bg2">
+                    <a:lumMod val="10000"/>
+                  </a:schemeClr>
+                </a:solidFill>
+                <a:latin typeface="Times New Roman" panose="02020603050405020304" pitchFamily="18" charset="0"/>
+                <a:cs typeface="Times New Roman" panose="02020603050405020304" pitchFamily="18" charset="0"/>
+              </a:rPr>
+              <a:t>RF 3 – Cadastro de pet</a:t>
             </a:r>
           </a:p>
           <a:p>
-            <a:endParaRPr lang="pt-BR" sz="3200" dirty="0"/>
-          </a:p>
-          <a:p>
-            <a:r>
-              <a:rPr lang="pt-BR" sz="3200" dirty="0"/>
-              <a:t>Registro de vacinação</a:t>
-            </a:r>
-          </a:p>
-          <a:p>
-            <a:endParaRPr lang="pt-BR" sz="3200" dirty="0"/>
-          </a:p>
-          <a:p>
-            <a:r>
-              <a:rPr lang="pt-BR" sz="3200" dirty="0"/>
-              <a:t>Agendamento de vacinas</a:t>
-            </a:r>
-          </a:p>
-          <a:p>
-            <a:endParaRPr lang="pt-BR" sz="3200" dirty="0"/>
-          </a:p>
-          <a:p>
-            <a:r>
-              <a:rPr lang="pt-BR" sz="3200" dirty="0"/>
-              <a:t>Divulgação de animais</a:t>
-            </a:r>
-          </a:p>
-          <a:p>
-            <a:endParaRPr lang="pt-BR" sz="3200" dirty="0">
+            <a:pPr algn="l"/>
+            <a:endParaRPr lang="pt-BR" sz="1800" dirty="0">
               <a:solidFill>
                 <a:schemeClr val="bg2">
                   <a:lumMod val="10000"/>
                 </a:schemeClr>
               </a:solidFill>
+              <a:latin typeface="Times New Roman" panose="02020603050405020304" pitchFamily="18" charset="0"/>
+              <a:cs typeface="Times New Roman" panose="02020603050405020304" pitchFamily="18" charset="0"/>
             </a:endParaRPr>
+          </a:p>
+          <a:p>
+            <a:pPr algn="l"/>
+            <a:r>
+              <a:rPr lang="pt-BR" sz="1800" dirty="0">
+                <a:solidFill>
+                  <a:schemeClr val="bg2">
+                    <a:lumMod val="10000"/>
+                  </a:schemeClr>
+                </a:solidFill>
+                <a:latin typeface="Times New Roman" panose="02020603050405020304" pitchFamily="18" charset="0"/>
+                <a:cs typeface="Times New Roman" panose="02020603050405020304" pitchFamily="18" charset="0"/>
+              </a:rPr>
+              <a:t>Descrição: O sistema deve permitir que o usuário cadastre um ou mais animais de estimação associados à sua conta.</a:t>
+            </a:r>
+          </a:p>
+          <a:p>
+            <a:pPr algn="l"/>
+            <a:r>
+              <a:rPr lang="pt-BR" sz="1800" b="1" dirty="0">
+                <a:solidFill>
+                  <a:schemeClr val="bg2">
+                    <a:lumMod val="10000"/>
+                  </a:schemeClr>
+                </a:solidFill>
+                <a:latin typeface="Times New Roman" panose="02020603050405020304" pitchFamily="18" charset="0"/>
+                <a:cs typeface="Times New Roman" panose="02020603050405020304" pitchFamily="18" charset="0"/>
+              </a:rPr>
+              <a:t>Entradas:</a:t>
+            </a:r>
+            <a:endParaRPr lang="pt-BR" sz="1800" dirty="0">
+              <a:solidFill>
+                <a:schemeClr val="bg2">
+                  <a:lumMod val="10000"/>
+                </a:schemeClr>
+              </a:solidFill>
+              <a:latin typeface="Times New Roman" panose="02020603050405020304" pitchFamily="18" charset="0"/>
+              <a:cs typeface="Times New Roman" panose="02020603050405020304" pitchFamily="18" charset="0"/>
+            </a:endParaRPr>
+          </a:p>
+          <a:p>
+            <a:pPr lvl="0" algn="l"/>
+            <a:r>
+              <a:rPr lang="pt-BR" sz="1800" dirty="0">
+                <a:solidFill>
+                  <a:schemeClr val="bg2">
+                    <a:lumMod val="10000"/>
+                  </a:schemeClr>
+                </a:solidFill>
+                <a:latin typeface="Times New Roman" panose="02020603050405020304" pitchFamily="18" charset="0"/>
+                <a:cs typeface="Times New Roman" panose="02020603050405020304" pitchFamily="18" charset="0"/>
+              </a:rPr>
+              <a:t>Nome do pet </a:t>
+            </a:r>
+          </a:p>
+          <a:p>
+            <a:pPr lvl="0" algn="l"/>
+            <a:r>
+              <a:rPr lang="pt-BR" sz="1800" dirty="0">
+                <a:solidFill>
+                  <a:schemeClr val="bg2">
+                    <a:lumMod val="10000"/>
+                  </a:schemeClr>
+                </a:solidFill>
+                <a:latin typeface="Times New Roman" panose="02020603050405020304" pitchFamily="18" charset="0"/>
+                <a:cs typeface="Times New Roman" panose="02020603050405020304" pitchFamily="18" charset="0"/>
+              </a:rPr>
+              <a:t>Espécie (cão, gato, etc.) </a:t>
+            </a:r>
+          </a:p>
+          <a:p>
+            <a:pPr lvl="0" algn="l"/>
+            <a:r>
+              <a:rPr lang="pt-BR" sz="1800" dirty="0">
+                <a:solidFill>
+                  <a:schemeClr val="bg2">
+                    <a:lumMod val="10000"/>
+                  </a:schemeClr>
+                </a:solidFill>
+                <a:latin typeface="Times New Roman" panose="02020603050405020304" pitchFamily="18" charset="0"/>
+                <a:cs typeface="Times New Roman" panose="02020603050405020304" pitchFamily="18" charset="0"/>
+              </a:rPr>
+              <a:t>Raça </a:t>
+            </a:r>
+          </a:p>
+          <a:p>
+            <a:pPr lvl="0" algn="l"/>
+            <a:r>
+              <a:rPr lang="pt-BR" sz="1800" dirty="0">
+                <a:solidFill>
+                  <a:schemeClr val="bg2">
+                    <a:lumMod val="10000"/>
+                  </a:schemeClr>
+                </a:solidFill>
+                <a:latin typeface="Times New Roman" panose="02020603050405020304" pitchFamily="18" charset="0"/>
+                <a:cs typeface="Times New Roman" panose="02020603050405020304" pitchFamily="18" charset="0"/>
+              </a:rPr>
+              <a:t>Idade </a:t>
+            </a:r>
+          </a:p>
+          <a:p>
+            <a:pPr lvl="0" algn="l"/>
+            <a:r>
+              <a:rPr lang="pt-BR" sz="1800" dirty="0">
+                <a:solidFill>
+                  <a:schemeClr val="bg2">
+                    <a:lumMod val="10000"/>
+                  </a:schemeClr>
+                </a:solidFill>
+                <a:latin typeface="Times New Roman" panose="02020603050405020304" pitchFamily="18" charset="0"/>
+                <a:cs typeface="Times New Roman" panose="02020603050405020304" pitchFamily="18" charset="0"/>
+              </a:rPr>
+              <a:t>Sexo </a:t>
+            </a:r>
+          </a:p>
+          <a:p>
+            <a:pPr lvl="0" algn="l"/>
+            <a:r>
+              <a:rPr lang="pt-BR" sz="1800" dirty="0">
+                <a:solidFill>
+                  <a:schemeClr val="bg2">
+                    <a:lumMod val="10000"/>
+                  </a:schemeClr>
+                </a:solidFill>
+                <a:latin typeface="Times New Roman" panose="02020603050405020304" pitchFamily="18" charset="0"/>
+                <a:cs typeface="Times New Roman" panose="02020603050405020304" pitchFamily="18" charset="0"/>
+              </a:rPr>
+              <a:t>Foto (opcional) </a:t>
+            </a:r>
+          </a:p>
+          <a:p>
+            <a:pPr lvl="0" algn="l"/>
+            <a:endParaRPr lang="pt-BR" sz="1800" dirty="0">
+              <a:solidFill>
+                <a:schemeClr val="bg2">
+                  <a:lumMod val="10000"/>
+                </a:schemeClr>
+              </a:solidFill>
+              <a:latin typeface="Times New Roman" panose="02020603050405020304" pitchFamily="18" charset="0"/>
+              <a:cs typeface="Times New Roman" panose="02020603050405020304" pitchFamily="18" charset="0"/>
+            </a:endParaRPr>
+          </a:p>
+          <a:p>
+            <a:pPr algn="l"/>
+            <a:r>
+              <a:rPr lang="pt-BR" sz="1800" b="1" dirty="0">
+                <a:solidFill>
+                  <a:schemeClr val="bg2">
+                    <a:lumMod val="10000"/>
+                  </a:schemeClr>
+                </a:solidFill>
+                <a:latin typeface="Times New Roman" panose="02020603050405020304" pitchFamily="18" charset="0"/>
+                <a:cs typeface="Times New Roman" panose="02020603050405020304" pitchFamily="18" charset="0"/>
+              </a:rPr>
+              <a:t>Processamento:</a:t>
+            </a:r>
+            <a:endParaRPr lang="pt-BR" sz="1800" dirty="0">
+              <a:solidFill>
+                <a:schemeClr val="bg2">
+                  <a:lumMod val="10000"/>
+                </a:schemeClr>
+              </a:solidFill>
+              <a:latin typeface="Times New Roman" panose="02020603050405020304" pitchFamily="18" charset="0"/>
+              <a:cs typeface="Times New Roman" panose="02020603050405020304" pitchFamily="18" charset="0"/>
+            </a:endParaRPr>
+          </a:p>
+          <a:p>
+            <a:pPr lvl="0" algn="l"/>
+            <a:r>
+              <a:rPr lang="pt-BR" sz="1800" dirty="0">
+                <a:solidFill>
+                  <a:schemeClr val="bg2">
+                    <a:lumMod val="10000"/>
+                  </a:schemeClr>
+                </a:solidFill>
+                <a:latin typeface="Times New Roman" panose="02020603050405020304" pitchFamily="18" charset="0"/>
+                <a:cs typeface="Times New Roman" panose="02020603050405020304" pitchFamily="18" charset="0"/>
+              </a:rPr>
+              <a:t>Associar o pet ao usuário logado </a:t>
+            </a:r>
+          </a:p>
+          <a:p>
+            <a:pPr lvl="0" algn="l"/>
+            <a:r>
+              <a:rPr lang="pt-BR" sz="1800" dirty="0">
+                <a:solidFill>
+                  <a:schemeClr val="bg2">
+                    <a:lumMod val="10000"/>
+                  </a:schemeClr>
+                </a:solidFill>
+                <a:latin typeface="Times New Roman" panose="02020603050405020304" pitchFamily="18" charset="0"/>
+                <a:cs typeface="Times New Roman" panose="02020603050405020304" pitchFamily="18" charset="0"/>
+              </a:rPr>
+              <a:t>Armazenar os dados no banco de dados </a:t>
+            </a:r>
+          </a:p>
+          <a:p>
+            <a:pPr lvl="0" algn="l"/>
+            <a:r>
+              <a:rPr lang="pt-BR" sz="1800" dirty="0">
+                <a:solidFill>
+                  <a:schemeClr val="bg2">
+                    <a:lumMod val="10000"/>
+                  </a:schemeClr>
+                </a:solidFill>
+                <a:latin typeface="Times New Roman" panose="02020603050405020304" pitchFamily="18" charset="0"/>
+                <a:cs typeface="Times New Roman" panose="02020603050405020304" pitchFamily="18" charset="0"/>
+              </a:rPr>
+              <a:t>Fazer upload da imagem (se houver) </a:t>
+            </a:r>
+          </a:p>
+          <a:p>
+            <a:pPr lvl="0" algn="l"/>
+            <a:endParaRPr lang="pt-BR" sz="1800" dirty="0">
+              <a:solidFill>
+                <a:schemeClr val="bg2">
+                  <a:lumMod val="10000"/>
+                </a:schemeClr>
+              </a:solidFill>
+              <a:latin typeface="Times New Roman" panose="02020603050405020304" pitchFamily="18" charset="0"/>
+              <a:cs typeface="Times New Roman" panose="02020603050405020304" pitchFamily="18" charset="0"/>
+            </a:endParaRPr>
+          </a:p>
+          <a:p>
+            <a:pPr algn="l"/>
+            <a:r>
+              <a:rPr lang="pt-BR" sz="1800" b="1" dirty="0">
+                <a:solidFill>
+                  <a:schemeClr val="bg2">
+                    <a:lumMod val="10000"/>
+                  </a:schemeClr>
+                </a:solidFill>
+                <a:latin typeface="Times New Roman" panose="02020603050405020304" pitchFamily="18" charset="0"/>
+                <a:cs typeface="Times New Roman" panose="02020603050405020304" pitchFamily="18" charset="0"/>
+              </a:rPr>
+              <a:t>Saída:</a:t>
+            </a:r>
+            <a:endParaRPr lang="pt-BR" sz="1800" dirty="0">
+              <a:solidFill>
+                <a:schemeClr val="bg2">
+                  <a:lumMod val="10000"/>
+                </a:schemeClr>
+              </a:solidFill>
+              <a:latin typeface="Times New Roman" panose="02020603050405020304" pitchFamily="18" charset="0"/>
+              <a:cs typeface="Times New Roman" panose="02020603050405020304" pitchFamily="18" charset="0"/>
+            </a:endParaRPr>
+          </a:p>
+          <a:p>
+            <a:pPr lvl="0" algn="l"/>
+            <a:r>
+              <a:rPr lang="pt-BR" sz="1800" dirty="0">
+                <a:solidFill>
+                  <a:schemeClr val="bg2">
+                    <a:lumMod val="10000"/>
+                  </a:schemeClr>
+                </a:solidFill>
+                <a:latin typeface="Times New Roman" panose="02020603050405020304" pitchFamily="18" charset="0"/>
+                <a:cs typeface="Times New Roman" panose="02020603050405020304" pitchFamily="18" charset="0"/>
+              </a:rPr>
+              <a:t>Pet cadastrado e exibido na lista do usuário </a:t>
+            </a:r>
+          </a:p>
+          <a:p>
+            <a:pPr lvl="0" algn="l"/>
+            <a:endParaRPr lang="pt-BR" sz="1800" dirty="0">
+              <a:solidFill>
+                <a:schemeClr val="bg2">
+                  <a:lumMod val="10000"/>
+                </a:schemeClr>
+              </a:solidFill>
+              <a:latin typeface="Times New Roman" panose="02020603050405020304" pitchFamily="18" charset="0"/>
+              <a:cs typeface="Times New Roman" panose="02020603050405020304" pitchFamily="18" charset="0"/>
+            </a:endParaRPr>
+          </a:p>
+          <a:p>
+            <a:pPr algn="l"/>
+            <a:r>
+              <a:rPr lang="pt-BR" sz="1800" b="1" dirty="0">
+                <a:solidFill>
+                  <a:schemeClr val="bg2">
+                    <a:lumMod val="10000"/>
+                  </a:schemeClr>
+                </a:solidFill>
+                <a:latin typeface="Times New Roman" panose="02020603050405020304" pitchFamily="18" charset="0"/>
+                <a:cs typeface="Times New Roman" panose="02020603050405020304" pitchFamily="18" charset="0"/>
+              </a:rPr>
+              <a:t>Regras de negócio:</a:t>
+            </a:r>
+            <a:endParaRPr lang="pt-BR" sz="1800" dirty="0">
+              <a:solidFill>
+                <a:schemeClr val="bg2">
+                  <a:lumMod val="10000"/>
+                </a:schemeClr>
+              </a:solidFill>
+              <a:latin typeface="Times New Roman" panose="02020603050405020304" pitchFamily="18" charset="0"/>
+              <a:cs typeface="Times New Roman" panose="02020603050405020304" pitchFamily="18" charset="0"/>
+            </a:endParaRPr>
+          </a:p>
+          <a:p>
+            <a:pPr lvl="0" algn="l"/>
+            <a:r>
+              <a:rPr lang="pt-BR" sz="1800" dirty="0">
+                <a:solidFill>
+                  <a:schemeClr val="bg2">
+                    <a:lumMod val="10000"/>
+                  </a:schemeClr>
+                </a:solidFill>
+                <a:latin typeface="Times New Roman" panose="02020603050405020304" pitchFamily="18" charset="0"/>
+                <a:cs typeface="Times New Roman" panose="02020603050405020304" pitchFamily="18" charset="0"/>
+              </a:rPr>
+              <a:t>Um usuário pode cadastrar múltiplos pets </a:t>
+            </a:r>
+          </a:p>
+          <a:p>
+            <a:pPr lvl="0" algn="l"/>
+            <a:r>
+              <a:rPr lang="pt-BR" sz="1800" dirty="0">
+                <a:solidFill>
+                  <a:schemeClr val="bg2">
+                    <a:lumMod val="10000"/>
+                  </a:schemeClr>
+                </a:solidFill>
+                <a:latin typeface="Times New Roman" panose="02020603050405020304" pitchFamily="18" charset="0"/>
+                <a:cs typeface="Times New Roman" panose="02020603050405020304" pitchFamily="18" charset="0"/>
+              </a:rPr>
+              <a:t>O nome do pet é obrigatório</a:t>
+            </a:r>
+          </a:p>
+          <a:p>
+            <a:pPr lvl="0" algn="l"/>
+            <a:endParaRPr lang="pt-BR" sz="1800" dirty="0">
+              <a:solidFill>
+                <a:schemeClr val="bg2">
+                  <a:lumMod val="10000"/>
+                </a:schemeClr>
+              </a:solidFill>
+              <a:latin typeface="Times New Roman" panose="02020603050405020304" pitchFamily="18" charset="0"/>
+              <a:cs typeface="Times New Roman" panose="02020603050405020304" pitchFamily="18" charset="0"/>
+            </a:endParaRPr>
+          </a:p>
+          <a:p>
+            <a:pPr algn="l"/>
+            <a:r>
+              <a:rPr lang="pt-BR" sz="1800" dirty="0">
+                <a:solidFill>
+                  <a:schemeClr val="bg2">
+                    <a:lumMod val="10000"/>
+                  </a:schemeClr>
+                </a:solidFill>
+                <a:latin typeface="Times New Roman" panose="02020603050405020304" pitchFamily="18" charset="0"/>
+                <a:cs typeface="Times New Roman" panose="02020603050405020304" pitchFamily="18" charset="0"/>
+              </a:rPr>
+              <a:t>Prioridade: (X) essencial   ( ) importante  ( ) desejável</a:t>
+            </a:r>
           </a:p>
         </p:txBody>
       </p:sp>
@@ -4251,7 +4796,7 @@
 </p:sld>
 </file>
 
-<file path=ppt/slides/slide5.xml><?xml version="1.0" encoding="utf-8"?>
+<file path=ppt/slides/slide6.xml><?xml version="1.0" encoding="utf-8"?>
 <p:sld xmlns:a="http://schemas.openxmlformats.org/drawingml/2006/main" xmlns:r="http://schemas.openxmlformats.org/officeDocument/2006/relationships" xmlns:p="http://schemas.openxmlformats.org/presentationml/2006/main">
   <p:cSld>
     <p:bg>
@@ -4340,8 +4885,8 @@
         </p:nvSpPr>
         <p:spPr>
           <a:xfrm>
-            <a:off x="0" y="2860863"/>
-            <a:ext cx="13004800" cy="4031873"/>
+            <a:off x="453728" y="4084712"/>
+            <a:ext cx="13004800" cy="2585323"/>
           </a:xfrm>
           <a:prstGeom prst="rect">
             <a:avLst/>
@@ -4372,45 +4917,126 @@
           </a:bodyPr>
           <a:lstStyle/>
           <a:p>
+            <a:pPr algn="l"/>
             <a:r>
-              <a:rPr lang="pt-BR" sz="3200" dirty="0"/>
-              <a:t>Sistema responsivo</a:t>
+              <a:rPr lang="pt-BR" sz="1800" b="1" dirty="0">
+                <a:solidFill>
+                  <a:schemeClr val="bg2">
+                    <a:lumMod val="10000"/>
+                  </a:schemeClr>
+                </a:solidFill>
+                <a:latin typeface="Times New Roman" panose="02020603050405020304" pitchFamily="18" charset="0"/>
+                <a:cs typeface="Times New Roman" panose="02020603050405020304" pitchFamily="18" charset="0"/>
+              </a:rPr>
+              <a:t>RNF 2 – Interface Clara</a:t>
             </a:r>
           </a:p>
           <a:p>
-            <a:endParaRPr lang="pt-BR" sz="3200" dirty="0"/>
-          </a:p>
-          <a:p>
+            <a:pPr algn="l"/>
             <a:r>
-              <a:rPr lang="pt-BR" sz="3200" dirty="0"/>
-              <a:t>Segurança dos dados</a:t>
+              <a:rPr lang="pt-BR" sz="1800" dirty="0">
+                <a:solidFill>
+                  <a:schemeClr val="bg2">
+                    <a:lumMod val="10000"/>
+                  </a:schemeClr>
+                </a:solidFill>
+                <a:latin typeface="Times New Roman" panose="02020603050405020304" pitchFamily="18" charset="0"/>
+                <a:cs typeface="Times New Roman" panose="02020603050405020304" pitchFamily="18" charset="0"/>
+              </a:rPr>
+              <a:t>Descrição: As devem ser apresentadas de forma clara e compreensível, sendo objetivo e para que leigos consigam ultiliza-los</a:t>
             </a:r>
           </a:p>
           <a:p>
-            <a:endParaRPr lang="pt-BR" sz="3200" dirty="0"/>
-          </a:p>
-          <a:p>
-            <a:r>
-              <a:rPr lang="pt-BR" sz="3200" dirty="0"/>
-              <a:t>Facilidade de uso</a:t>
-            </a:r>
-          </a:p>
-          <a:p>
-            <a:endParaRPr lang="pt-BR" sz="3200" dirty="0"/>
-          </a:p>
-          <a:p>
-            <a:r>
-              <a:rPr lang="pt-BR" sz="3200" dirty="0"/>
-              <a:t>Bom desempenho</a:t>
-            </a:r>
-          </a:p>
-          <a:p>
-            <a:endParaRPr lang="pt-BR" sz="3200" dirty="0">
+            <a:pPr algn="l"/>
+            <a:endParaRPr lang="pt-BR" sz="1800" b="1" dirty="0">
               <a:solidFill>
                 <a:schemeClr val="bg2">
                   <a:lumMod val="10000"/>
                 </a:schemeClr>
               </a:solidFill>
+              <a:latin typeface="Times New Roman" panose="02020603050405020304" pitchFamily="18" charset="0"/>
+              <a:cs typeface="Times New Roman" panose="02020603050405020304" pitchFamily="18" charset="0"/>
+            </a:endParaRPr>
+          </a:p>
+          <a:p>
+            <a:pPr algn="l"/>
+            <a:endParaRPr lang="pt-BR" sz="1800" b="1" dirty="0">
+              <a:solidFill>
+                <a:schemeClr val="bg2">
+                  <a:lumMod val="10000"/>
+                </a:schemeClr>
+              </a:solidFill>
+              <a:latin typeface="Times New Roman" panose="02020603050405020304" pitchFamily="18" charset="0"/>
+              <a:cs typeface="Times New Roman" panose="02020603050405020304" pitchFamily="18" charset="0"/>
+            </a:endParaRPr>
+          </a:p>
+          <a:p>
+            <a:pPr algn="l"/>
+            <a:r>
+              <a:rPr lang="pt-BR" sz="1800" b="1" dirty="0">
+                <a:solidFill>
+                  <a:schemeClr val="bg2">
+                    <a:lumMod val="10000"/>
+                  </a:schemeClr>
+                </a:solidFill>
+                <a:latin typeface="Times New Roman" panose="02020603050405020304" pitchFamily="18" charset="0"/>
+                <a:cs typeface="Times New Roman" panose="02020603050405020304" pitchFamily="18" charset="0"/>
+              </a:rPr>
+              <a:t>RNF  9 – Possível integração futura</a:t>
+            </a:r>
+          </a:p>
+          <a:p>
+            <a:pPr algn="l"/>
+            <a:r>
+              <a:rPr lang="pt-BR" sz="1800" dirty="0">
+                <a:solidFill>
+                  <a:schemeClr val="bg2">
+                    <a:lumMod val="10000"/>
+                  </a:schemeClr>
+                </a:solidFill>
+                <a:latin typeface="Times New Roman" panose="02020603050405020304" pitchFamily="18" charset="0"/>
+                <a:cs typeface="Times New Roman" panose="02020603050405020304" pitchFamily="18" charset="0"/>
+              </a:rPr>
+              <a:t>Descrição: O sistema pode permitir integração com outros sistemas no futuro.</a:t>
+            </a:r>
+          </a:p>
+          <a:p>
+            <a:pPr algn="l"/>
+            <a:r>
+              <a:rPr lang="pt-BR" sz="1800" dirty="0">
+                <a:solidFill>
+                  <a:schemeClr val="bg2">
+                    <a:lumMod val="10000"/>
+                  </a:schemeClr>
+                </a:solidFill>
+                <a:latin typeface="Times New Roman" panose="02020603050405020304" pitchFamily="18" charset="0"/>
+                <a:cs typeface="Times New Roman" panose="02020603050405020304" pitchFamily="18" charset="0"/>
+              </a:rPr>
+              <a:t>Exemplo: Integração com um aplicativo mobile</a:t>
+            </a:r>
+          </a:p>
+          <a:p>
+            <a:pPr algn="l"/>
+            <a:endParaRPr lang="pt-BR" sz="1800" dirty="0">
+              <a:solidFill>
+                <a:schemeClr val="bg2">
+                  <a:lumMod val="10000"/>
+                </a:schemeClr>
+              </a:solidFill>
+              <a:latin typeface="Times New Roman" panose="02020603050405020304" pitchFamily="18" charset="0"/>
+              <a:cs typeface="Times New Roman" panose="02020603050405020304" pitchFamily="18" charset="0"/>
+            </a:endParaRPr>
+          </a:p>
+          <a:p>
+            <a:pPr algn="l"/>
+            <a:endParaRPr lang="pt-BR" sz="1800" dirty="0">
+              <a:solidFill>
+                <a:schemeClr val="bg2">
+                  <a:lumMod val="10000"/>
+                </a:schemeClr>
+              </a:solidFill>
+              <a:latin typeface="Times New Roman" panose="02020603050405020304" pitchFamily="18" charset="0"/>
+              <a:cs typeface="Times New Roman" panose="02020603050405020304" pitchFamily="18" charset="0"/>
             </a:endParaRPr>
           </a:p>
         </p:txBody>
@@ -4419,184 +5045,6 @@
     <p:extLst>
       <p:ext uri="{BB962C8B-B14F-4D97-AF65-F5344CB8AC3E}">
         <p14:creationId xmlns:p14="http://schemas.microsoft.com/office/powerpoint/2010/main" val="925246302"/>
-      </p:ext>
-    </p:extLst>
-  </p:cSld>
-  <p:clrMapOvr>
-    <a:masterClrMapping/>
-  </p:clrMapOvr>
-  <p:transition spd="med"/>
-</p:sld>
-</file>
-
-<file path=ppt/slides/slide6.xml><?xml version="1.0" encoding="utf-8"?>
-<p:sld xmlns:a="http://schemas.openxmlformats.org/drawingml/2006/main" xmlns:r="http://schemas.openxmlformats.org/officeDocument/2006/relationships" xmlns:p="http://schemas.openxmlformats.org/presentationml/2006/main">
-  <p:cSld>
-    <p:bg>
-      <p:bgPr>
-        <a:blipFill rotWithShape="1">
-          <a:blip r:embed="rId2"/>
-          <a:srcRect/>
-          <a:stretch>
-            <a:fillRect/>
-          </a:stretch>
-        </a:blipFill>
-        <a:effectLst/>
-      </p:bgPr>
-    </p:bg>
-    <p:spTree>
-      <p:nvGrpSpPr>
-        <p:cNvPr id="1" name="">
-          <a:extLst>
-            <a:ext uri="{FF2B5EF4-FFF2-40B4-BE49-F238E27FC236}">
-              <a16:creationId xmlns:a16="http://schemas.microsoft.com/office/drawing/2014/main" id="{C0E6F5A5-9834-EFAF-B959-3D99FB1836B0}"/>
-            </a:ext>
-          </a:extLst>
-        </p:cNvPr>
-        <p:cNvGrpSpPr/>
-        <p:nvPr/>
-      </p:nvGrpSpPr>
-      <p:grpSpPr>
-        <a:xfrm>
-          <a:off x="0" y="0"/>
-          <a:ext cx="0" cy="0"/>
-          <a:chOff x="0" y="0"/>
-          <a:chExt cx="0" cy="0"/>
-        </a:xfrm>
-      </p:grpSpPr>
-      <p:sp>
-        <p:nvSpPr>
-          <p:cNvPr id="154" name="Título da Apresentação">
-            <a:extLst>
-              <a:ext uri="{FF2B5EF4-FFF2-40B4-BE49-F238E27FC236}">
-                <a16:creationId xmlns:a16="http://schemas.microsoft.com/office/drawing/2014/main" id="{A2DA51BC-4A8F-9940-5645-CC2F96998972}"/>
-              </a:ext>
-            </a:extLst>
-          </p:cNvPr>
-          <p:cNvSpPr txBox="1">
-            <a:spLocks noGrp="1"/>
-          </p:cNvSpPr>
-          <p:nvPr>
-            <p:ph type="ctrTitle" idx="4294967295"/>
-          </p:nvPr>
-        </p:nvSpPr>
-        <p:spPr>
-          <a:xfrm>
-            <a:off x="2325936" y="484312"/>
-            <a:ext cx="10225136" cy="1512168"/>
-          </a:xfrm>
-          <a:prstGeom prst="rect">
-            <a:avLst/>
-          </a:prstGeom>
-        </p:spPr>
-        <p:txBody>
-          <a:bodyPr>
-            <a:normAutofit/>
-          </a:bodyPr>
-          <a:lstStyle/>
-          <a:p>
-            <a:pPr algn="ctr"/>
-            <a:r>
-              <a:rPr lang="pt-BR" dirty="0"/>
-              <a:t>Análise dos Requisitos</a:t>
-            </a:r>
-            <a:endParaRPr dirty="0"/>
-          </a:p>
-        </p:txBody>
-      </p:sp>
-      <p:sp>
-        <p:nvSpPr>
-          <p:cNvPr id="3" name="CaixaDeTexto 2">
-            <a:extLst>
-              <a:ext uri="{FF2B5EF4-FFF2-40B4-BE49-F238E27FC236}">
-                <a16:creationId xmlns:a16="http://schemas.microsoft.com/office/drawing/2014/main" id="{026D0FF9-78FD-AC17-4E3C-CD5A8CCBA553}"/>
-              </a:ext>
-            </a:extLst>
-          </p:cNvPr>
-          <p:cNvSpPr txBox="1"/>
-          <p:nvPr/>
-        </p:nvSpPr>
-        <p:spPr>
-          <a:xfrm>
-            <a:off x="0" y="2860863"/>
-            <a:ext cx="13004800" cy="4031873"/>
-          </a:xfrm>
-          <a:prstGeom prst="rect">
-            <a:avLst/>
-          </a:prstGeom>
-          <a:noFill/>
-          <a:ln w="12700" cap="flat">
-            <a:noFill/>
-            <a:miter lim="400000"/>
-          </a:ln>
-          <a:effectLst/>
-          <a:sp3d/>
-        </p:spPr>
-        <p:style>
-          <a:lnRef idx="0">
-            <a:scrgbClr r="0" g="0" b="0"/>
-          </a:lnRef>
-          <a:fillRef idx="0">
-            <a:scrgbClr r="0" g="0" b="0"/>
-          </a:fillRef>
-          <a:effectRef idx="0">
-            <a:scrgbClr r="0" g="0" b="0"/>
-          </a:effectRef>
-          <a:fontRef idx="none"/>
-        </p:style>
-        <p:txBody>
-          <a:bodyPr wrap="square">
-            <a:spAutoFit/>
-          </a:bodyPr>
-          <a:lstStyle/>
-          <a:p>
-            <a:r>
-              <a:rPr lang="pt-BR" sz="3200" dirty="0"/>
-              <a:t>Validação com entrevistas</a:t>
-            </a:r>
-          </a:p>
-          <a:p>
-            <a:endParaRPr lang="pt-BR" sz="3200" dirty="0"/>
-          </a:p>
-          <a:p>
-            <a:r>
-              <a:rPr lang="pt-BR" sz="3200" dirty="0"/>
-              <a:t>Priorização das funcionalidades</a:t>
-            </a:r>
-          </a:p>
-          <a:p>
-            <a:endParaRPr lang="pt-BR" sz="3200" dirty="0"/>
-          </a:p>
-          <a:p>
-            <a:r>
-              <a:rPr lang="pt-BR" sz="3200" dirty="0"/>
-              <a:t>Identificação de melhorias</a:t>
-            </a:r>
-          </a:p>
-          <a:p>
-            <a:endParaRPr lang="pt-BR" sz="3200" dirty="0"/>
-          </a:p>
-          <a:p>
-            <a:r>
-              <a:rPr lang="pt-BR" sz="3200" dirty="0"/>
-              <a:t>Ajustes conforme usuários</a:t>
-            </a:r>
-          </a:p>
-          <a:p>
-            <a:endParaRPr lang="pt-BR" sz="3200" dirty="0">
-              <a:solidFill>
-                <a:schemeClr val="bg2">
-                  <a:lumMod val="10000"/>
-                </a:schemeClr>
-              </a:solidFill>
-            </a:endParaRPr>
-          </a:p>
-        </p:txBody>
-      </p:sp>
-    </p:spTree>
-    <p:extLst>
-      <p:ext uri="{BB962C8B-B14F-4D97-AF65-F5344CB8AC3E}">
-        <p14:creationId xmlns:p14="http://schemas.microsoft.com/office/powerpoint/2010/main" val="1675470032"/>
       </p:ext>
     </p:extLst>
   </p:cSld>
@@ -4675,110 +5123,49 @@
           <a:p>
             <a:pPr algn="ctr"/>
             <a:r>
-              <a:rPr lang="pt-BR" dirty="0"/>
-              <a:t>Diagrama</a:t>
-            </a:r>
-            <a:r>
-              <a:rPr lang="pt-BR" b="0" dirty="0"/>
-              <a:t> </a:t>
-            </a:r>
-            <a:r>
-              <a:rPr lang="pt-BR" dirty="0"/>
-              <a:t>de Caso de Uso</a:t>
+              <a:rPr lang="en-US" dirty="0"/>
+              <a:t>Modelo de Dados</a:t>
             </a:r>
             <a:endParaRPr dirty="0"/>
           </a:p>
         </p:txBody>
       </p:sp>
-      <p:sp>
-        <p:nvSpPr>
-          <p:cNvPr id="3" name="CaixaDeTexto 2">
+      <p:pic>
+        <p:nvPicPr>
+          <p:cNvPr id="4" name="Picture 3">
             <a:extLst>
               <a:ext uri="{FF2B5EF4-FFF2-40B4-BE49-F238E27FC236}">
-                <a16:creationId xmlns:a16="http://schemas.microsoft.com/office/drawing/2014/main" id="{10E2A6CB-3EF7-9D3C-2B1C-7436FE5AB12B}"/>
+                <a16:creationId xmlns:a16="http://schemas.microsoft.com/office/drawing/2014/main" id="{5D650841-7C94-9AA3-6D34-893062C09C31}"/>
               </a:ext>
             </a:extLst>
           </p:cNvPr>
-          <p:cNvSpPr txBox="1"/>
+          <p:cNvPicPr>
+            <a:picLocks noChangeAspect="1"/>
+          </p:cNvPicPr>
           <p:nvPr/>
-        </p:nvSpPr>
+        </p:nvPicPr>
+        <p:blipFill>
+          <a:blip r:embed="rId3">
+            <a:extLst>
+              <a:ext uri="{28A0092B-C50C-407E-A947-70E740481C1C}">
+                <a14:useLocalDpi xmlns:a14="http://schemas.microsoft.com/office/drawing/2010/main" val="0"/>
+              </a:ext>
+            </a:extLst>
+          </a:blip>
+          <a:stretch>
+            <a:fillRect/>
+          </a:stretch>
+        </p:blipFill>
         <p:spPr>
           <a:xfrm>
-            <a:off x="0" y="2860863"/>
-            <a:ext cx="13004800" cy="4031873"/>
+            <a:off x="1821880" y="1636440"/>
+            <a:ext cx="9915525" cy="7248525"/>
           </a:xfrm>
           <a:prstGeom prst="rect">
             <a:avLst/>
           </a:prstGeom>
-          <a:noFill/>
-          <a:ln w="12700" cap="flat">
-            <a:noFill/>
-            <a:miter lim="400000"/>
-          </a:ln>
-          <a:effectLst/>
-          <a:sp3d/>
         </p:spPr>
-        <p:style>
-          <a:lnRef idx="0">
-            <a:scrgbClr r="0" g="0" b="0"/>
-          </a:lnRef>
-          <a:fillRef idx="0">
-            <a:scrgbClr r="0" g="0" b="0"/>
-          </a:fillRef>
-          <a:effectRef idx="0">
-            <a:scrgbClr r="0" g="0" b="0"/>
-          </a:effectRef>
-          <a:fontRef idx="none"/>
-        </p:style>
-        <p:txBody>
-          <a:bodyPr wrap="square">
-            <a:spAutoFit/>
-          </a:bodyPr>
-          <a:lstStyle/>
-          <a:p>
-            <a:r>
-              <a:rPr lang="pt-BR" sz="3200" dirty="0"/>
-              <a:t>Validação com entrevistas</a:t>
-            </a:r>
-          </a:p>
-          <a:p>
-            <a:endParaRPr lang="pt-BR" sz="3200" dirty="0"/>
-          </a:p>
-          <a:p>
-            <a:r>
-              <a:rPr lang="pt-BR" sz="3200" dirty="0"/>
-              <a:t>Priorização das funcionalidades</a:t>
-            </a:r>
-          </a:p>
-          <a:p>
-            <a:endParaRPr lang="pt-BR" sz="3200" dirty="0"/>
-          </a:p>
-          <a:p>
-            <a:r>
-              <a:rPr lang="pt-BR" sz="3200" dirty="0"/>
-              <a:t>Identificação de melhorias</a:t>
-            </a:r>
-          </a:p>
-          <a:p>
-            <a:endParaRPr lang="pt-BR" sz="3200" dirty="0"/>
-          </a:p>
-          <a:p>
-            <a:r>
-              <a:rPr lang="pt-BR" sz="3200" dirty="0"/>
-              <a:t>Ajustes conforme usuários</a:t>
-            </a:r>
-          </a:p>
-          <a:p>
-            <a:endParaRPr lang="pt-BR" sz="3200" dirty="0">
-              <a:solidFill>
-                <a:schemeClr val="bg2">
-                  <a:lumMod val="10000"/>
-                </a:schemeClr>
-              </a:solidFill>
-            </a:endParaRPr>
-          </a:p>
-        </p:txBody>
-      </p:sp>
+      </p:pic>
     </p:spTree>
     <p:extLst>
       <p:ext uri="{BB962C8B-B14F-4D97-AF65-F5344CB8AC3E}">
@@ -4794,6 +5181,139 @@
 </file>
 
 <file path=ppt/slides/slide8.xml><?xml version="1.0" encoding="utf-8"?>
+<p:sld xmlns:a="http://schemas.openxmlformats.org/drawingml/2006/main" xmlns:r="http://schemas.openxmlformats.org/officeDocument/2006/relationships" xmlns:p="http://schemas.openxmlformats.org/presentationml/2006/main">
+  <p:cSld>
+    <p:bg>
+      <p:bgPr>
+        <a:blipFill rotWithShape="1">
+          <a:blip r:embed="rId2"/>
+          <a:srcRect/>
+          <a:stretch>
+            <a:fillRect/>
+          </a:stretch>
+        </a:blipFill>
+        <a:effectLst/>
+      </p:bgPr>
+    </p:bg>
+    <p:spTree>
+      <p:nvGrpSpPr>
+        <p:cNvPr id="1" name="">
+          <a:extLst>
+            <a:ext uri="{FF2B5EF4-FFF2-40B4-BE49-F238E27FC236}">
+              <a16:creationId xmlns:a16="http://schemas.microsoft.com/office/drawing/2014/main" id="{DC3AD252-CE73-8474-D3AD-355A3726EAFF}"/>
+            </a:ext>
+          </a:extLst>
+        </p:cNvPr>
+        <p:cNvGrpSpPr/>
+        <p:nvPr/>
+      </p:nvGrpSpPr>
+      <p:grpSpPr>
+        <a:xfrm>
+          <a:off x="0" y="0"/>
+          <a:ext cx="0" cy="0"/>
+          <a:chOff x="0" y="0"/>
+          <a:chExt cx="0" cy="0"/>
+        </a:xfrm>
+      </p:grpSpPr>
+      <p:sp>
+        <p:nvSpPr>
+          <p:cNvPr id="154" name="Título da Apresentação">
+            <a:extLst>
+              <a:ext uri="{FF2B5EF4-FFF2-40B4-BE49-F238E27FC236}">
+                <a16:creationId xmlns:a16="http://schemas.microsoft.com/office/drawing/2014/main" id="{DE82A6F5-DCE6-240A-29B5-272AFC9374DD}"/>
+              </a:ext>
+            </a:extLst>
+          </p:cNvPr>
+          <p:cNvSpPr txBox="1">
+            <a:spLocks noGrp="1"/>
+          </p:cNvSpPr>
+          <p:nvPr>
+            <p:ph type="ctrTitle" idx="4294967295"/>
+          </p:nvPr>
+        </p:nvSpPr>
+        <p:spPr>
+          <a:xfrm>
+            <a:off x="2613968" y="340296"/>
+            <a:ext cx="10225136" cy="1512168"/>
+          </a:xfrm>
+          <a:prstGeom prst="rect">
+            <a:avLst/>
+          </a:prstGeom>
+        </p:spPr>
+        <p:txBody>
+          <a:bodyPr>
+            <a:normAutofit/>
+          </a:bodyPr>
+          <a:lstStyle/>
+          <a:p>
+            <a:pPr algn="ctr"/>
+            <a:r>
+              <a:rPr lang="pt-BR" dirty="0"/>
+              <a:t>Diagrama</a:t>
+            </a:r>
+            <a:r>
+              <a:rPr lang="pt-BR" b="0" dirty="0"/>
+              <a:t> </a:t>
+            </a:r>
+            <a:r>
+              <a:rPr lang="pt-BR" dirty="0"/>
+              <a:t>de Caso de Uso</a:t>
+            </a:r>
+            <a:endParaRPr dirty="0"/>
+          </a:p>
+        </p:txBody>
+      </p:sp>
+      <p:pic>
+        <p:nvPicPr>
+          <p:cNvPr id="3" name="Picture 2">
+            <a:extLst>
+              <a:ext uri="{FF2B5EF4-FFF2-40B4-BE49-F238E27FC236}">
+                <a16:creationId xmlns:a16="http://schemas.microsoft.com/office/drawing/2014/main" id="{5E77106F-31EA-8AEF-0E58-66FBC154EDD7}"/>
+              </a:ext>
+            </a:extLst>
+          </p:cNvPr>
+          <p:cNvPicPr>
+            <a:picLocks noChangeAspect="1"/>
+          </p:cNvPicPr>
+          <p:nvPr/>
+        </p:nvPicPr>
+        <p:blipFill>
+          <a:blip r:embed="rId3">
+            <a:extLst>
+              <a:ext uri="{28A0092B-C50C-407E-A947-70E740481C1C}">
+                <a14:useLocalDpi xmlns:a14="http://schemas.microsoft.com/office/drawing/2010/main" val="0"/>
+              </a:ext>
+            </a:extLst>
+          </a:blip>
+          <a:stretch>
+            <a:fillRect/>
+          </a:stretch>
+        </p:blipFill>
+        <p:spPr>
+          <a:xfrm>
+            <a:off x="2974008" y="1132384"/>
+            <a:ext cx="6508099" cy="8578520"/>
+          </a:xfrm>
+          <a:prstGeom prst="rect">
+            <a:avLst/>
+          </a:prstGeom>
+        </p:spPr>
+      </p:pic>
+    </p:spTree>
+    <p:extLst>
+      <p:ext uri="{BB962C8B-B14F-4D97-AF65-F5344CB8AC3E}">
+        <p14:creationId xmlns:p14="http://schemas.microsoft.com/office/powerpoint/2010/main" val="3698094919"/>
+      </p:ext>
+    </p:extLst>
+  </p:cSld>
+  <p:clrMapOvr>
+    <a:masterClrMapping/>
+  </p:clrMapOvr>
+  <p:transition spd="med"/>
+</p:sld>
+</file>
+
+<file path=ppt/slides/slide9.xml><?xml version="1.0" encoding="utf-8"?>
 <p:sld xmlns:a="http://schemas.openxmlformats.org/drawingml/2006/main" xmlns:r="http://schemas.openxmlformats.org/officeDocument/2006/relationships" xmlns:p="http://schemas.openxmlformats.org/presentationml/2006/main">
   <p:cSld>
     <p:bg>
@@ -4867,12 +5387,42 @@
           </a:p>
         </p:txBody>
       </p:sp>
+      <p:pic>
+        <p:nvPicPr>
+          <p:cNvPr id="7" name="Picture 6">
+            <a:extLst>
+              <a:ext uri="{FF2B5EF4-FFF2-40B4-BE49-F238E27FC236}">
+                <a16:creationId xmlns:a16="http://schemas.microsoft.com/office/drawing/2014/main" id="{FF47F73E-81D6-6665-B090-A09B5984E33A}"/>
+              </a:ext>
+            </a:extLst>
+          </p:cNvPr>
+          <p:cNvPicPr>
+            <a:picLocks noChangeAspect="1"/>
+          </p:cNvPicPr>
+          <p:nvPr/>
+        </p:nvPicPr>
+        <p:blipFill>
+          <a:blip r:embed="rId3"/>
+          <a:stretch>
+            <a:fillRect/>
+          </a:stretch>
+        </p:blipFill>
+        <p:spPr>
+          <a:xfrm>
+            <a:off x="0" y="3076600"/>
+            <a:ext cx="13004800" cy="5028834"/>
+          </a:xfrm>
+          <a:prstGeom prst="rect">
+            <a:avLst/>
+          </a:prstGeom>
+        </p:spPr>
+      </p:pic>
       <p:sp>
         <p:nvSpPr>
-          <p:cNvPr id="3" name="CaixaDeTexto 2">
+          <p:cNvPr id="8" name="TextBox 7">
             <a:extLst>
               <a:ext uri="{FF2B5EF4-FFF2-40B4-BE49-F238E27FC236}">
-                <a16:creationId xmlns:a16="http://schemas.microsoft.com/office/drawing/2014/main" id="{56A2FB01-959F-D81E-883A-2553FB121249}"/>
+                <a16:creationId xmlns:a16="http://schemas.microsoft.com/office/drawing/2014/main" id="{BFC14D60-D740-6923-75CB-779FE002A6AF}"/>
               </a:ext>
             </a:extLst>
           </p:cNvPr>
@@ -4881,8 +5431,8 @@
         </p:nvSpPr>
         <p:spPr>
           <a:xfrm>
-            <a:off x="0" y="2860863"/>
-            <a:ext cx="13004800" cy="4031873"/>
+            <a:off x="165696" y="2428528"/>
+            <a:ext cx="3240360" cy="471924"/>
           </a:xfrm>
           <a:prstGeom prst="rect">
             <a:avLst/>
@@ -4908,50 +5458,95 @@
           <a:fontRef idx="none"/>
         </p:style>
         <p:txBody>
-          <a:bodyPr wrap="square">
+          <a:bodyPr rot="0" spcFirstLastPara="1" vertOverflow="overflow" horzOverflow="overflow" vert="horz" wrap="square" lIns="50800" tIns="50800" rIns="50800" bIns="50800" numCol="1" spcCol="38100" rtlCol="0" anchor="ctr">
             <a:spAutoFit/>
           </a:bodyPr>
           <a:lstStyle/>
           <a:p>
+            <a:pPr marL="0" marR="0" indent="0" algn="ctr" defTabSz="1733930" rtl="0" fontAlgn="auto" latinLnBrk="0" hangingPunct="0">
+              <a:lnSpc>
+                <a:spcPct val="100000"/>
+              </a:lnSpc>
+              <a:spcBef>
+                <a:spcPts val="0"/>
+              </a:spcBef>
+              <a:spcAft>
+                <a:spcPts val="0"/>
+              </a:spcAft>
+              <a:buClrTx/>
+              <a:buSzTx/>
+              <a:buFontTx/>
+              <a:buNone/>
+              <a:tabLst/>
+            </a:pPr>
             <a:r>
-              <a:rPr lang="pt-BR" sz="3200" dirty="0"/>
-              <a:t>Validação com entrevistas</a:t>
+              <a:rPr kumimoji="0" lang="en-US" sz="2400" b="1" i="0" u="none" strike="noStrike" cap="none" spc="0" normalizeH="0" baseline="0" dirty="0" err="1">
+                <a:ln>
+                  <a:noFill/>
+                </a:ln>
+                <a:solidFill>
+                  <a:schemeClr val="bg2">
+                    <a:lumMod val="10000"/>
+                  </a:schemeClr>
+                </a:solidFill>
+                <a:effectLst/>
+                <a:uFillTx/>
+                <a:latin typeface="Times New Roman" panose="02020603050405020304" pitchFamily="18" charset="0"/>
+                <a:cs typeface="Times New Roman" panose="02020603050405020304" pitchFamily="18" charset="0"/>
+                <a:sym typeface="Helvetica Neue"/>
+              </a:rPr>
+              <a:t>Cadastrar</a:t>
             </a:r>
-          </a:p>
-          <a:p>
-            <a:endParaRPr lang="pt-BR" sz="3200" dirty="0"/>
-          </a:p>
-          <a:p>
             <a:r>
-              <a:rPr lang="pt-BR" sz="3200" dirty="0"/>
-              <a:t>Priorização das funcionalidades</a:t>
+              <a:rPr kumimoji="0" lang="en-US" sz="2400" b="1" i="0" u="none" strike="noStrike" cap="none" spc="0" normalizeH="0" baseline="0" dirty="0">
+                <a:ln>
+                  <a:noFill/>
+                </a:ln>
+                <a:solidFill>
+                  <a:schemeClr val="bg2">
+                    <a:lumMod val="10000"/>
+                  </a:schemeClr>
+                </a:solidFill>
+                <a:effectLst/>
+                <a:uFillTx/>
+                <a:latin typeface="Times New Roman" panose="02020603050405020304" pitchFamily="18" charset="0"/>
+                <a:cs typeface="Times New Roman" panose="02020603050405020304" pitchFamily="18" charset="0"/>
+                <a:sym typeface="Helvetica Neue"/>
+              </a:rPr>
+              <a:t> </a:t>
             </a:r>
-          </a:p>
-          <a:p>
-            <a:endParaRPr lang="pt-BR" sz="3200" dirty="0"/>
-          </a:p>
-          <a:p>
             <a:r>
-              <a:rPr lang="pt-BR" sz="3200" dirty="0"/>
-              <a:t>Identificação de melhorias</a:t>
+              <a:rPr kumimoji="0" lang="en-US" sz="2400" b="1" i="0" u="none" strike="noStrike" cap="none" spc="0" normalizeH="0" baseline="0" dirty="0" err="1">
+                <a:ln>
+                  <a:noFill/>
+                </a:ln>
+                <a:solidFill>
+                  <a:schemeClr val="bg2">
+                    <a:lumMod val="10000"/>
+                  </a:schemeClr>
+                </a:solidFill>
+                <a:effectLst/>
+                <a:uFillTx/>
+                <a:latin typeface="Times New Roman" panose="02020603050405020304" pitchFamily="18" charset="0"/>
+                <a:cs typeface="Times New Roman" panose="02020603050405020304" pitchFamily="18" charset="0"/>
+                <a:sym typeface="Helvetica Neue"/>
+              </a:rPr>
+              <a:t>Vacinação</a:t>
             </a:r>
-          </a:p>
-          <a:p>
-            <a:endParaRPr lang="pt-BR" sz="3200" dirty="0"/>
-          </a:p>
-          <a:p>
-            <a:r>
-              <a:rPr lang="pt-BR" sz="3200" dirty="0"/>
-              <a:t>Ajustes conforme usuários</a:t>
-            </a:r>
-          </a:p>
-          <a:p>
-            <a:endParaRPr lang="pt-BR" sz="3200" dirty="0">
+            <a:endParaRPr kumimoji="0" lang="pt-BR" sz="2400" b="1" i="0" u="none" strike="noStrike" cap="none" spc="0" normalizeH="0" baseline="0" dirty="0">
+              <a:ln>
+                <a:noFill/>
+              </a:ln>
               <a:solidFill>
                 <a:schemeClr val="bg2">
                   <a:lumMod val="10000"/>
                 </a:schemeClr>
               </a:solidFill>
+              <a:effectLst/>
+              <a:uFillTx/>
+              <a:latin typeface="Times New Roman" panose="02020603050405020304" pitchFamily="18" charset="0"/>
+              <a:cs typeface="Times New Roman" panose="02020603050405020304" pitchFamily="18" charset="0"/>
+              <a:sym typeface="Helvetica Neue"/>
             </a:endParaRPr>
           </a:p>
         </p:txBody>

</xml_diff>